<commit_message>
feat: add fluid dynamics application slide to PowerPoint deck
</commit_message>
<xml_diff>
--- a/docs/MJWarp_MJX_PhysX_机器人仿真选型.pptx
+++ b/docs/MJWarp_MJX_PhysX_机器人仿真选型.pptx
@@ -22,6 +22,7 @@
     <p:sldId id="270" r:id="rId21"/>
     <p:sldId id="271" r:id="rId22"/>
     <p:sldId id="272" r:id="rId23"/>
+    <p:sldId id="273" r:id="rId24"/>
   </p:sldIdLst>
   <p:notesMasterIdLst>
     <p:notesMasterId r:id="rId12"/>
@@ -21651,6 +21652,2476 @@
                 <a:latin typeface="Noto Sans CJK SC"/>
               </a:rPr>
               <a:t>17</a:t>
+            </a:r>
+          </a:p>
+        </p:txBody>
+      </p:sp>
+    </p:spTree>
+  </p:cSld>
+  <p:clrMapOvr>
+    <a:masterClrMapping/>
+  </p:clrMapOvr>
+</p:sld>
+</file>
+
+<file path=ppt/slides/slide18.xml><?xml version="1.0" encoding="utf-8"?>
+<p:sld xmlns:a="http://schemas.openxmlformats.org/drawingml/2006/main" xmlns:p="http://schemas.openxmlformats.org/presentationml/2006/main" xmlns:r="http://schemas.openxmlformats.org/officeDocument/2006/relationships">
+  <p:cSld>
+    <p:spTree>
+      <p:nvGrpSpPr>
+        <p:cNvPr id="1" name=""/>
+        <p:cNvGrpSpPr/>
+        <p:nvPr/>
+      </p:nvGrpSpPr>
+      <p:grpSpPr/>
+      <p:sp>
+        <p:nvSpPr>
+          <p:cNvPr id="2" name="Rectangle 1"/>
+          <p:cNvSpPr/>
+          <p:nvPr/>
+        </p:nvSpPr>
+        <p:spPr>
+          <a:xfrm>
+            <a:off x="822960" y="566928"/>
+            <a:ext cx="566928" cy="566928"/>
+          </a:xfrm>
+          <a:prstGeom prst="rect">
+            <a:avLst/>
+          </a:prstGeom>
+          <a:solidFill>
+            <a:srgbClr val="026BFF"/>
+          </a:solidFill>
+          <a:ln>
+            <a:noFill/>
+          </a:ln>
+        </p:spPr>
+        <p:style>
+          <a:lnRef idx="1">
+            <a:schemeClr val="accent1"/>
+          </a:lnRef>
+          <a:fillRef idx="3">
+            <a:schemeClr val="accent1"/>
+          </a:fillRef>
+          <a:effectRef idx="2">
+            <a:schemeClr val="accent1"/>
+          </a:effectRef>
+          <a:fontRef idx="minor">
+            <a:schemeClr val="lt1"/>
+          </a:fontRef>
+        </p:style>
+        <p:txBody>
+          <a:bodyPr rtlCol="0" anchor="ctr"/>
+          <a:lstStyle/>
+          <a:p>
+            <a:pPr algn="ctr"/>
+          </a:p>
+        </p:txBody>
+      </p:sp>
+      <p:sp>
+        <p:nvSpPr>
+          <p:cNvPr id="3" name="TextBox 2"/>
+          <p:cNvSpPr txBox="1"/>
+          <p:nvPr/>
+        </p:nvSpPr>
+        <p:spPr>
+          <a:xfrm>
+            <a:off x="822960" y="566928"/>
+            <a:ext cx="566928" cy="566928"/>
+          </a:xfrm>
+          <a:prstGeom prst="rect">
+            <a:avLst/>
+          </a:prstGeom>
+          <a:noFill/>
+        </p:spPr>
+        <p:txBody>
+          <a:bodyPr wrap="square" lIns="0" rIns="0" tIns="0" bIns="0" anchor="ctr">
+            <a:spAutoFit/>
+          </a:bodyPr>
+          <a:lstStyle/>
+          <a:p>
+            <a:pPr algn="ctr">
+              <a:lnSpc>
+                <a:spcPct val="100000"/>
+              </a:lnSpc>
+              <a:spcBef>
+                <a:spcPts val="0"/>
+              </a:spcBef>
+              <a:spcAft>
+                <a:spcPts val="0"/>
+              </a:spcAft>
+            </a:pPr>
+            <a:r>
+              <a:rPr sz="1900" b="1">
+                <a:solidFill>
+                  <a:srgbClr val="FFFFFF"/>
+                </a:solidFill>
+                <a:latin typeface="Noto Sans CJK SC"/>
+              </a:rPr>
+              <a:t>A6</a:t>
+            </a:r>
+          </a:p>
+        </p:txBody>
+      </p:sp>
+      <p:sp>
+        <p:nvSpPr>
+          <p:cNvPr id="4" name="TextBox 3"/>
+          <p:cNvSpPr txBox="1"/>
+          <p:nvPr/>
+        </p:nvSpPr>
+        <p:spPr>
+          <a:xfrm>
+            <a:off x="1536192" y="548640"/>
+            <a:ext cx="9601200" cy="292608"/>
+          </a:xfrm>
+          <a:prstGeom prst="rect">
+            <a:avLst/>
+          </a:prstGeom>
+          <a:noFill/>
+        </p:spPr>
+        <p:txBody>
+          <a:bodyPr wrap="square" lIns="0" rIns="0" tIns="0" bIns="0" anchor="ctr">
+            <a:spAutoFit/>
+          </a:bodyPr>
+          <a:lstStyle/>
+          <a:p>
+            <a:pPr algn="l">
+              <a:lnSpc>
+                <a:spcPct val="100000"/>
+              </a:lnSpc>
+              <a:spcBef>
+                <a:spcPts val="0"/>
+              </a:spcBef>
+              <a:spcAft>
+                <a:spcPts val="0"/>
+              </a:spcAft>
+            </a:pPr>
+            <a:r>
+              <a:rPr sz="1050" b="1">
+                <a:solidFill>
+                  <a:srgbClr val="026BFF"/>
+                </a:solidFill>
+                <a:latin typeface="Noto Sans CJK SC"/>
+              </a:rPr>
+              <a:t>APPENDIX  / FLUID DYNAMICS</a:t>
+            </a:r>
+          </a:p>
+        </p:txBody>
+      </p:sp>
+      <p:sp>
+        <p:nvSpPr>
+          <p:cNvPr id="5" name="TextBox 4"/>
+          <p:cNvSpPr txBox="1"/>
+          <p:nvPr/>
+        </p:nvSpPr>
+        <p:spPr>
+          <a:xfrm>
+            <a:off x="1517904" y="832104"/>
+            <a:ext cx="9829800" cy="530352"/>
+          </a:xfrm>
+          <a:prstGeom prst="rect">
+            <a:avLst/>
+          </a:prstGeom>
+          <a:noFill/>
+        </p:spPr>
+        <p:txBody>
+          <a:bodyPr wrap="square" lIns="0" rIns="0" tIns="0" bIns="0" anchor="ctr">
+            <a:spAutoFit/>
+          </a:bodyPr>
+          <a:lstStyle/>
+          <a:p>
+            <a:pPr algn="l">
+              <a:lnSpc>
+                <a:spcPct val="100000"/>
+              </a:lnSpc>
+              <a:spcBef>
+                <a:spcPts val="0"/>
+              </a:spcBef>
+              <a:spcAft>
+                <a:spcPts val="0"/>
+              </a:spcAft>
+            </a:pPr>
+            <a:r>
+              <a:rPr sz="2700" b="1">
+                <a:solidFill>
+                  <a:srgbClr val="262626"/>
+                </a:solidFill>
+                <a:latin typeface="Noto Sans CJK SC"/>
+              </a:rPr>
+              <a:t>流体动力学：从 Navier–Stokes 到粒子—网格耦合</a:t>
+            </a:r>
+          </a:p>
+        </p:txBody>
+      </p:sp>
+      <p:sp>
+        <p:nvSpPr>
+          <p:cNvPr id="6" name="Rounded Rectangle 5"/>
+          <p:cNvSpPr/>
+          <p:nvPr/>
+        </p:nvSpPr>
+        <p:spPr>
+          <a:xfrm>
+            <a:off x="822960" y="1682496"/>
+            <a:ext cx="3154680" cy="4315968"/>
+          </a:xfrm>
+          <a:prstGeom prst="roundRect">
+            <a:avLst>
+              <a:gd name="adj" fmla="val 8000"/>
+            </a:avLst>
+          </a:prstGeom>
+          <a:solidFill>
+            <a:srgbClr val="0A2350"/>
+          </a:solidFill>
+          <a:ln>
+            <a:noFill/>
+          </a:ln>
+        </p:spPr>
+        <p:style>
+          <a:lnRef idx="1">
+            <a:schemeClr val="accent1"/>
+          </a:lnRef>
+          <a:fillRef idx="3">
+            <a:schemeClr val="accent1"/>
+          </a:fillRef>
+          <a:effectRef idx="2">
+            <a:schemeClr val="accent1"/>
+          </a:effectRef>
+          <a:fontRef idx="minor">
+            <a:schemeClr val="lt1"/>
+          </a:fontRef>
+        </p:style>
+        <p:txBody>
+          <a:bodyPr rtlCol="0" anchor="ctr"/>
+          <a:lstStyle/>
+          <a:p>
+            <a:pPr algn="ctr"/>
+          </a:p>
+        </p:txBody>
+      </p:sp>
+      <p:sp>
+        <p:nvSpPr>
+          <p:cNvPr id="7" name="TextBox 6"/>
+          <p:cNvSpPr txBox="1"/>
+          <p:nvPr/>
+        </p:nvSpPr>
+        <p:spPr>
+          <a:xfrm>
+            <a:off x="960120" y="1984248"/>
+            <a:ext cx="2880360" cy="530352"/>
+          </a:xfrm>
+          <a:prstGeom prst="rect">
+            <a:avLst/>
+          </a:prstGeom>
+          <a:noFill/>
+        </p:spPr>
+        <p:txBody>
+          <a:bodyPr wrap="square" lIns="0" rIns="0" tIns="0" bIns="0" anchor="ctr">
+            <a:spAutoFit/>
+          </a:bodyPr>
+          <a:lstStyle/>
+          <a:p>
+            <a:pPr algn="ctr">
+              <a:lnSpc>
+                <a:spcPct val="100000"/>
+              </a:lnSpc>
+              <a:spcBef>
+                <a:spcPts val="0"/>
+              </a:spcBef>
+              <a:spcAft>
+                <a:spcPts val="0"/>
+              </a:spcAft>
+            </a:pPr>
+            <a:r>
+              <a:rPr sz="1800" b="1">
+                <a:solidFill>
+                  <a:srgbClr val="FFFFFF"/>
+                </a:solidFill>
+                <a:latin typeface="Noto Sans Mono CJK SC"/>
+              </a:rPr>
+              <a:t>ρ(∂u/∂t + u·∇u)</a:t>
+            </a:r>
+          </a:p>
+        </p:txBody>
+      </p:sp>
+      <p:sp>
+        <p:nvSpPr>
+          <p:cNvPr id="8" name="TextBox 7"/>
+          <p:cNvSpPr txBox="1"/>
+          <p:nvPr/>
+        </p:nvSpPr>
+        <p:spPr>
+          <a:xfrm>
+            <a:off x="960120" y="2514600"/>
+            <a:ext cx="2880360" cy="475488"/>
+          </a:xfrm>
+          <a:prstGeom prst="rect">
+            <a:avLst/>
+          </a:prstGeom>
+          <a:noFill/>
+        </p:spPr>
+        <p:txBody>
+          <a:bodyPr wrap="square" lIns="0" rIns="0" tIns="0" bIns="0" anchor="ctr">
+            <a:spAutoFit/>
+          </a:bodyPr>
+          <a:lstStyle/>
+          <a:p>
+            <a:pPr algn="ctr">
+              <a:lnSpc>
+                <a:spcPct val="100000"/>
+              </a:lnSpc>
+              <a:spcBef>
+                <a:spcPts val="0"/>
+              </a:spcBef>
+              <a:spcAft>
+                <a:spcPts val="0"/>
+              </a:spcAft>
+            </a:pPr>
+            <a:r>
+              <a:rPr sz="1700" b="1">
+                <a:solidFill>
+                  <a:srgbClr val="19B7FF"/>
+                </a:solidFill>
+                <a:latin typeface="Noto Sans Mono CJK SC"/>
+              </a:rPr>
+              <a:t>= −∇p + μ∇²u + f</a:t>
+            </a:r>
+          </a:p>
+        </p:txBody>
+      </p:sp>
+      <p:cxnSp>
+        <p:nvCxnSpPr>
+          <p:cNvPr id="9" name="Connector 8"/>
+          <p:cNvCxnSpPr/>
+          <p:nvPr/>
+        </p:nvCxnSpPr>
+        <p:spPr>
+          <a:xfrm>
+            <a:off x="1261872" y="3209544"/>
+            <a:ext cx="2276856" cy="0"/>
+          </a:xfrm>
+          <a:prstGeom prst="line">
+            <a:avLst/>
+          </a:prstGeom>
+          <a:ln w="12700">
+            <a:solidFill>
+              <a:srgbClr val="2A417A"/>
+            </a:solidFill>
+          </a:ln>
+        </p:spPr>
+        <p:style>
+          <a:lnRef idx="2">
+            <a:schemeClr val="accent1"/>
+          </a:lnRef>
+          <a:fillRef idx="0">
+            <a:schemeClr val="accent1"/>
+          </a:fillRef>
+          <a:effectRef idx="1">
+            <a:schemeClr val="accent1"/>
+          </a:effectRef>
+          <a:fontRef idx="minor">
+            <a:schemeClr val="tx1"/>
+          </a:fontRef>
+        </p:style>
+      </p:cxnSp>
+      <p:sp>
+        <p:nvSpPr>
+          <p:cNvPr id="10" name="TextBox 9"/>
+          <p:cNvSpPr txBox="1"/>
+          <p:nvPr/>
+        </p:nvSpPr>
+        <p:spPr>
+          <a:xfrm>
+            <a:off x="1005840" y="3383280"/>
+            <a:ext cx="2788920" cy="438912"/>
+          </a:xfrm>
+          <a:prstGeom prst="rect">
+            <a:avLst/>
+          </a:prstGeom>
+          <a:noFill/>
+        </p:spPr>
+        <p:txBody>
+          <a:bodyPr wrap="square" lIns="0" rIns="0" tIns="0" bIns="0" anchor="ctr">
+            <a:spAutoFit/>
+          </a:bodyPr>
+          <a:lstStyle/>
+          <a:p>
+            <a:pPr algn="ctr">
+              <a:lnSpc>
+                <a:spcPct val="100000"/>
+              </a:lnSpc>
+              <a:spcBef>
+                <a:spcPts val="0"/>
+              </a:spcBef>
+              <a:spcAft>
+                <a:spcPts val="0"/>
+              </a:spcAft>
+            </a:pPr>
+            <a:r>
+              <a:rPr sz="2300" b="1">
+                <a:solidFill>
+                  <a:srgbClr val="FFFFFF"/>
+                </a:solidFill>
+                <a:latin typeface="Noto Sans Mono CJK SC"/>
+              </a:rPr>
+              <a:t>∇·u = 0</a:t>
+            </a:r>
+          </a:p>
+        </p:txBody>
+      </p:sp>
+      <p:sp>
+        <p:nvSpPr>
+          <p:cNvPr id="11" name="TextBox 10"/>
+          <p:cNvSpPr txBox="1"/>
+          <p:nvPr/>
+        </p:nvSpPr>
+        <p:spPr>
+          <a:xfrm>
+            <a:off x="1115568" y="3950208"/>
+            <a:ext cx="2560320" cy="329184"/>
+          </a:xfrm>
+          <a:prstGeom prst="rect">
+            <a:avLst/>
+          </a:prstGeom>
+          <a:noFill/>
+        </p:spPr>
+        <p:txBody>
+          <a:bodyPr wrap="square" lIns="0" rIns="0" tIns="0" bIns="0" anchor="ctr">
+            <a:spAutoFit/>
+          </a:bodyPr>
+          <a:lstStyle/>
+          <a:p>
+            <a:pPr algn="ctr">
+              <a:lnSpc>
+                <a:spcPct val="100000"/>
+              </a:lnSpc>
+              <a:spcBef>
+                <a:spcPts val="0"/>
+              </a:spcBef>
+              <a:spcAft>
+                <a:spcPts val="0"/>
+              </a:spcAft>
+            </a:pPr>
+            <a:r>
+              <a:rPr sz="1350" b="1">
+                <a:solidFill>
+                  <a:srgbClr val="19B7FF"/>
+                </a:solidFill>
+                <a:latin typeface="Noto Sans CJK SC"/>
+              </a:rPr>
+              <a:t>Warp 加速环节</a:t>
+            </a:r>
+          </a:p>
+        </p:txBody>
+      </p:sp>
+      <p:sp>
+        <p:nvSpPr>
+          <p:cNvPr id="12" name="Oval 11"/>
+          <p:cNvSpPr/>
+          <p:nvPr/>
+        </p:nvSpPr>
+        <p:spPr>
+          <a:xfrm>
+            <a:off x="1280160" y="4465015"/>
+            <a:ext cx="100584" cy="100584"/>
+          </a:xfrm>
+          <a:prstGeom prst="ellipse">
+            <a:avLst/>
+          </a:prstGeom>
+          <a:solidFill>
+            <a:srgbClr val="19B7FF"/>
+          </a:solidFill>
+          <a:ln>
+            <a:noFill/>
+          </a:ln>
+        </p:spPr>
+        <p:style>
+          <a:lnRef idx="1">
+            <a:schemeClr val="accent1"/>
+          </a:lnRef>
+          <a:fillRef idx="3">
+            <a:schemeClr val="accent1"/>
+          </a:fillRef>
+          <a:effectRef idx="2">
+            <a:schemeClr val="accent1"/>
+          </a:effectRef>
+          <a:fontRef idx="minor">
+            <a:schemeClr val="lt1"/>
+          </a:fontRef>
+        </p:style>
+        <p:txBody>
+          <a:bodyPr rtlCol="0" anchor="ctr"/>
+          <a:lstStyle/>
+          <a:p>
+            <a:pPr algn="ctr"/>
+          </a:p>
+        </p:txBody>
+      </p:sp>
+      <p:sp>
+        <p:nvSpPr>
+          <p:cNvPr id="13" name="TextBox 12"/>
+          <p:cNvSpPr txBox="1"/>
+          <p:nvPr/>
+        </p:nvSpPr>
+        <p:spPr>
+          <a:xfrm>
+            <a:off x="1508760" y="4361688"/>
+            <a:ext cx="2103120" cy="365760"/>
+          </a:xfrm>
+          <a:prstGeom prst="rect">
+            <a:avLst/>
+          </a:prstGeom>
+          <a:noFill/>
+        </p:spPr>
+        <p:txBody>
+          <a:bodyPr wrap="square" lIns="0" rIns="0" tIns="0" bIns="0" anchor="ctr">
+            <a:spAutoFit/>
+          </a:bodyPr>
+          <a:lstStyle/>
+          <a:p>
+            <a:pPr algn="l">
+              <a:lnSpc>
+                <a:spcPct val="100000"/>
+              </a:lnSpc>
+              <a:spcBef>
+                <a:spcPts val="0"/>
+              </a:spcBef>
+              <a:spcAft>
+                <a:spcPts val="0"/>
+              </a:spcAft>
+            </a:pPr>
+            <a:r>
+              <a:rPr sz="1000" b="0">
+                <a:solidFill>
+                  <a:srgbClr val="C4CFE6"/>
+                </a:solidFill>
+                <a:latin typeface="Noto Sans CJK SC"/>
+              </a:rPr>
+              <a:t>对流与扩散更新</a:t>
+            </a:r>
+          </a:p>
+        </p:txBody>
+      </p:sp>
+      <p:sp>
+        <p:nvSpPr>
+          <p:cNvPr id="14" name="Oval 13"/>
+          <p:cNvSpPr/>
+          <p:nvPr/>
+        </p:nvSpPr>
+        <p:spPr>
+          <a:xfrm>
+            <a:off x="1280160" y="4830775"/>
+            <a:ext cx="100584" cy="100584"/>
+          </a:xfrm>
+          <a:prstGeom prst="ellipse">
+            <a:avLst/>
+          </a:prstGeom>
+          <a:solidFill>
+            <a:srgbClr val="19B7FF"/>
+          </a:solidFill>
+          <a:ln>
+            <a:noFill/>
+          </a:ln>
+        </p:spPr>
+        <p:style>
+          <a:lnRef idx="1">
+            <a:schemeClr val="accent1"/>
+          </a:lnRef>
+          <a:fillRef idx="3">
+            <a:schemeClr val="accent1"/>
+          </a:fillRef>
+          <a:effectRef idx="2">
+            <a:schemeClr val="accent1"/>
+          </a:effectRef>
+          <a:fontRef idx="minor">
+            <a:schemeClr val="lt1"/>
+          </a:fontRef>
+        </p:style>
+        <p:txBody>
+          <a:bodyPr rtlCol="0" anchor="ctr"/>
+          <a:lstStyle/>
+          <a:p>
+            <a:pPr algn="ctr"/>
+          </a:p>
+        </p:txBody>
+      </p:sp>
+      <p:sp>
+        <p:nvSpPr>
+          <p:cNvPr id="15" name="TextBox 14"/>
+          <p:cNvSpPr txBox="1"/>
+          <p:nvPr/>
+        </p:nvSpPr>
+        <p:spPr>
+          <a:xfrm>
+            <a:off x="1508760" y="4727448"/>
+            <a:ext cx="2103120" cy="365760"/>
+          </a:xfrm>
+          <a:prstGeom prst="rect">
+            <a:avLst/>
+          </a:prstGeom>
+          <a:noFill/>
+        </p:spPr>
+        <p:txBody>
+          <a:bodyPr wrap="square" lIns="0" rIns="0" tIns="0" bIns="0" anchor="ctr">
+            <a:spAutoFit/>
+          </a:bodyPr>
+          <a:lstStyle/>
+          <a:p>
+            <a:pPr algn="l">
+              <a:lnSpc>
+                <a:spcPct val="100000"/>
+              </a:lnSpc>
+              <a:spcBef>
+                <a:spcPts val="0"/>
+              </a:spcBef>
+              <a:spcAft>
+                <a:spcPts val="0"/>
+              </a:spcAft>
+            </a:pPr>
+            <a:r>
+              <a:rPr sz="1000" b="0">
+                <a:solidFill>
+                  <a:srgbClr val="C4CFE6"/>
+                </a:solidFill>
+                <a:latin typeface="Noto Sans CJK SC"/>
+              </a:rPr>
+              <a:t>压力投影 / 稀疏求解</a:t>
+            </a:r>
+          </a:p>
+        </p:txBody>
+      </p:sp>
+      <p:sp>
+        <p:nvSpPr>
+          <p:cNvPr id="16" name="Oval 15"/>
+          <p:cNvSpPr/>
+          <p:nvPr/>
+        </p:nvSpPr>
+        <p:spPr>
+          <a:xfrm>
+            <a:off x="1280160" y="5196535"/>
+            <a:ext cx="100584" cy="100584"/>
+          </a:xfrm>
+          <a:prstGeom prst="ellipse">
+            <a:avLst/>
+          </a:prstGeom>
+          <a:solidFill>
+            <a:srgbClr val="19B7FF"/>
+          </a:solidFill>
+          <a:ln>
+            <a:noFill/>
+          </a:ln>
+        </p:spPr>
+        <p:style>
+          <a:lnRef idx="1">
+            <a:schemeClr val="accent1"/>
+          </a:lnRef>
+          <a:fillRef idx="3">
+            <a:schemeClr val="accent1"/>
+          </a:fillRef>
+          <a:effectRef idx="2">
+            <a:schemeClr val="accent1"/>
+          </a:effectRef>
+          <a:fontRef idx="minor">
+            <a:schemeClr val="lt1"/>
+          </a:fontRef>
+        </p:style>
+        <p:txBody>
+          <a:bodyPr rtlCol="0" anchor="ctr"/>
+          <a:lstStyle/>
+          <a:p>
+            <a:pPr algn="ctr"/>
+          </a:p>
+        </p:txBody>
+      </p:sp>
+      <p:sp>
+        <p:nvSpPr>
+          <p:cNvPr id="17" name="TextBox 16"/>
+          <p:cNvSpPr txBox="1"/>
+          <p:nvPr/>
+        </p:nvSpPr>
+        <p:spPr>
+          <a:xfrm>
+            <a:off x="1508760" y="5093207"/>
+            <a:ext cx="2103120" cy="365760"/>
+          </a:xfrm>
+          <a:prstGeom prst="rect">
+            <a:avLst/>
+          </a:prstGeom>
+          <a:noFill/>
+        </p:spPr>
+        <p:txBody>
+          <a:bodyPr wrap="square" lIns="0" rIns="0" tIns="0" bIns="0" anchor="ctr">
+            <a:spAutoFit/>
+          </a:bodyPr>
+          <a:lstStyle/>
+          <a:p>
+            <a:pPr algn="l">
+              <a:lnSpc>
+                <a:spcPct val="100000"/>
+              </a:lnSpc>
+              <a:spcBef>
+                <a:spcPts val="0"/>
+              </a:spcBef>
+              <a:spcAft>
+                <a:spcPts val="0"/>
+              </a:spcAft>
+            </a:pPr>
+            <a:r>
+              <a:rPr sz="1000" b="0">
+                <a:solidFill>
+                  <a:srgbClr val="C4CFE6"/>
+                </a:solidFill>
+                <a:latin typeface="Noto Sans CJK SC"/>
+              </a:rPr>
+              <a:t>粒子—网格传输</a:t>
+            </a:r>
+          </a:p>
+        </p:txBody>
+      </p:sp>
+      <p:sp>
+        <p:nvSpPr>
+          <p:cNvPr id="18" name="Oval 17"/>
+          <p:cNvSpPr/>
+          <p:nvPr/>
+        </p:nvSpPr>
+        <p:spPr>
+          <a:xfrm>
+            <a:off x="1280160" y="5562295"/>
+            <a:ext cx="100584" cy="100584"/>
+          </a:xfrm>
+          <a:prstGeom prst="ellipse">
+            <a:avLst/>
+          </a:prstGeom>
+          <a:solidFill>
+            <a:srgbClr val="19B7FF"/>
+          </a:solidFill>
+          <a:ln>
+            <a:noFill/>
+          </a:ln>
+        </p:spPr>
+        <p:style>
+          <a:lnRef idx="1">
+            <a:schemeClr val="accent1"/>
+          </a:lnRef>
+          <a:fillRef idx="3">
+            <a:schemeClr val="accent1"/>
+          </a:fillRef>
+          <a:effectRef idx="2">
+            <a:schemeClr val="accent1"/>
+          </a:effectRef>
+          <a:fontRef idx="minor">
+            <a:schemeClr val="lt1"/>
+          </a:fontRef>
+        </p:style>
+        <p:txBody>
+          <a:bodyPr rtlCol="0" anchor="ctr"/>
+          <a:lstStyle/>
+          <a:p>
+            <a:pPr algn="ctr"/>
+          </a:p>
+        </p:txBody>
+      </p:sp>
+      <p:sp>
+        <p:nvSpPr>
+          <p:cNvPr id="19" name="TextBox 18"/>
+          <p:cNvSpPr txBox="1"/>
+          <p:nvPr/>
+        </p:nvSpPr>
+        <p:spPr>
+          <a:xfrm>
+            <a:off x="1508760" y="5458968"/>
+            <a:ext cx="2103120" cy="365760"/>
+          </a:xfrm>
+          <a:prstGeom prst="rect">
+            <a:avLst/>
+          </a:prstGeom>
+          <a:noFill/>
+        </p:spPr>
+        <p:txBody>
+          <a:bodyPr wrap="square" lIns="0" rIns="0" tIns="0" bIns="0" anchor="ctr">
+            <a:spAutoFit/>
+          </a:bodyPr>
+          <a:lstStyle/>
+          <a:p>
+            <a:pPr algn="l">
+              <a:lnSpc>
+                <a:spcPct val="100000"/>
+              </a:lnSpc>
+              <a:spcBef>
+                <a:spcPts val="0"/>
+              </a:spcBef>
+              <a:spcAft>
+                <a:spcPts val="0"/>
+              </a:spcAft>
+            </a:pPr>
+            <a:r>
+              <a:rPr sz="1000" b="0">
+                <a:solidFill>
+                  <a:srgbClr val="C4CFE6"/>
+                </a:solidFill>
+                <a:latin typeface="Noto Sans CJK SC"/>
+              </a:rPr>
+              <a:t>批量场景与梯度</a:t>
+            </a:r>
+          </a:p>
+        </p:txBody>
+      </p:sp>
+      <p:sp>
+        <p:nvSpPr>
+          <p:cNvPr id="20" name="Rounded Rectangle 19"/>
+          <p:cNvSpPr/>
+          <p:nvPr/>
+        </p:nvSpPr>
+        <p:spPr>
+          <a:xfrm>
+            <a:off x="4297680" y="1682496"/>
+            <a:ext cx="7040880" cy="1051560"/>
+          </a:xfrm>
+          <a:prstGeom prst="roundRect">
+            <a:avLst>
+              <a:gd name="adj" fmla="val 8000"/>
+            </a:avLst>
+          </a:prstGeom>
+          <a:solidFill>
+            <a:srgbClr val="FFFFFF"/>
+          </a:solidFill>
+          <a:ln w="12700">
+            <a:solidFill>
+              <a:srgbClr val="E4E9F2"/>
+            </a:solidFill>
+          </a:ln>
+        </p:spPr>
+        <p:style>
+          <a:lnRef idx="1">
+            <a:schemeClr val="accent1"/>
+          </a:lnRef>
+          <a:fillRef idx="3">
+            <a:schemeClr val="accent1"/>
+          </a:fillRef>
+          <a:effectRef idx="2">
+            <a:schemeClr val="accent1"/>
+          </a:effectRef>
+          <a:fontRef idx="minor">
+            <a:schemeClr val="lt1"/>
+          </a:fontRef>
+        </p:style>
+        <p:txBody>
+          <a:bodyPr rtlCol="0" anchor="ctr"/>
+          <a:lstStyle/>
+          <a:p>
+            <a:pPr algn="ctr"/>
+          </a:p>
+        </p:txBody>
+      </p:sp>
+      <p:sp>
+        <p:nvSpPr>
+          <p:cNvPr id="21" name="Rectangle 20"/>
+          <p:cNvSpPr/>
+          <p:nvPr/>
+        </p:nvSpPr>
+        <p:spPr>
+          <a:xfrm>
+            <a:off x="4526280" y="1911095"/>
+            <a:ext cx="566928" cy="566928"/>
+          </a:xfrm>
+          <a:prstGeom prst="rect">
+            <a:avLst/>
+          </a:prstGeom>
+          <a:solidFill>
+            <a:srgbClr val="026BFF"/>
+          </a:solidFill>
+          <a:ln>
+            <a:noFill/>
+          </a:ln>
+        </p:spPr>
+        <p:style>
+          <a:lnRef idx="1">
+            <a:schemeClr val="accent1"/>
+          </a:lnRef>
+          <a:fillRef idx="3">
+            <a:schemeClr val="accent1"/>
+          </a:fillRef>
+          <a:effectRef idx="2">
+            <a:schemeClr val="accent1"/>
+          </a:effectRef>
+          <a:fontRef idx="minor">
+            <a:schemeClr val="lt1"/>
+          </a:fontRef>
+        </p:style>
+        <p:txBody>
+          <a:bodyPr rtlCol="0" anchor="ctr"/>
+          <a:lstStyle/>
+          <a:p>
+            <a:pPr algn="ctr"/>
+          </a:p>
+        </p:txBody>
+      </p:sp>
+      <p:sp>
+        <p:nvSpPr>
+          <p:cNvPr id="22" name="TextBox 21"/>
+          <p:cNvSpPr txBox="1"/>
+          <p:nvPr/>
+        </p:nvSpPr>
+        <p:spPr>
+          <a:xfrm>
+            <a:off x="4526280" y="1911095"/>
+            <a:ext cx="566928" cy="566928"/>
+          </a:xfrm>
+          <a:prstGeom prst="rect">
+            <a:avLst/>
+          </a:prstGeom>
+          <a:noFill/>
+        </p:spPr>
+        <p:txBody>
+          <a:bodyPr wrap="square" lIns="0" rIns="0" tIns="0" bIns="0" anchor="ctr">
+            <a:spAutoFit/>
+          </a:bodyPr>
+          <a:lstStyle/>
+          <a:p>
+            <a:pPr algn="ctr">
+              <a:lnSpc>
+                <a:spcPct val="100000"/>
+              </a:lnSpc>
+              <a:spcBef>
+                <a:spcPts val="0"/>
+              </a:spcBef>
+              <a:spcAft>
+                <a:spcPts val="0"/>
+              </a:spcAft>
+            </a:pPr>
+            <a:r>
+              <a:rPr sz="1250" b="1">
+                <a:solidFill>
+                  <a:srgbClr val="FFFFFF"/>
+                </a:solidFill>
+                <a:latin typeface="Noto Sans CJK SC"/>
+              </a:rPr>
+              <a:t>01</a:t>
+            </a:r>
+          </a:p>
+        </p:txBody>
+      </p:sp>
+      <p:sp>
+        <p:nvSpPr>
+          <p:cNvPr id="23" name="TextBox 22"/>
+          <p:cNvSpPr txBox="1"/>
+          <p:nvPr/>
+        </p:nvSpPr>
+        <p:spPr>
+          <a:xfrm>
+            <a:off x="5330952" y="1801368"/>
+            <a:ext cx="2057400" cy="347472"/>
+          </a:xfrm>
+          <a:prstGeom prst="rect">
+            <a:avLst/>
+          </a:prstGeom>
+          <a:noFill/>
+        </p:spPr>
+        <p:txBody>
+          <a:bodyPr wrap="square" lIns="0" rIns="0" tIns="0" bIns="0" anchor="ctr">
+            <a:spAutoFit/>
+          </a:bodyPr>
+          <a:lstStyle/>
+          <a:p>
+            <a:pPr algn="l">
+              <a:lnSpc>
+                <a:spcPct val="100000"/>
+              </a:lnSpc>
+              <a:spcBef>
+                <a:spcPts val="0"/>
+              </a:spcBef>
+              <a:spcAft>
+                <a:spcPts val="0"/>
+              </a:spcAft>
+            </a:pPr>
+            <a:r>
+              <a:rPr sz="1450" b="1">
+                <a:solidFill>
+                  <a:srgbClr val="262626"/>
+                </a:solidFill>
+                <a:latin typeface="Noto Sans CJK SC"/>
+              </a:rPr>
+              <a:t>warp.fem 路径</a:t>
+            </a:r>
+          </a:p>
+        </p:txBody>
+      </p:sp>
+      <p:sp>
+        <p:nvSpPr>
+          <p:cNvPr id="24" name="TextBox 23"/>
+          <p:cNvSpPr txBox="1"/>
+          <p:nvPr/>
+        </p:nvSpPr>
+        <p:spPr>
+          <a:xfrm>
+            <a:off x="5330952" y="2148840"/>
+            <a:ext cx="2240280" cy="448056"/>
+          </a:xfrm>
+          <a:prstGeom prst="rect">
+            <a:avLst/>
+          </a:prstGeom>
+          <a:noFill/>
+        </p:spPr>
+        <p:txBody>
+          <a:bodyPr wrap="square" lIns="0" rIns="0" tIns="0" bIns="0" anchor="ctr">
+            <a:spAutoFit/>
+          </a:bodyPr>
+          <a:lstStyle/>
+          <a:p>
+            <a:pPr algn="l">
+              <a:lnSpc>
+                <a:spcPct val="100000"/>
+              </a:lnSpc>
+              <a:spcBef>
+                <a:spcPts val="0"/>
+              </a:spcBef>
+              <a:spcAft>
+                <a:spcPts val="0"/>
+              </a:spcAft>
+            </a:pPr>
+            <a:r>
+              <a:rPr sz="950" b="0">
+                <a:solidFill>
+                  <a:srgbClr val="727171"/>
+                </a:solidFill>
+                <a:latin typeface="Noto Sans CJK SC"/>
+              </a:rPr>
+              <a:t>Stokes / Navier–Stokes
+速度—压力混合空间</a:t>
+            </a:r>
+          </a:p>
+        </p:txBody>
+      </p:sp>
+      <p:sp>
+        <p:nvSpPr>
+          <p:cNvPr id="25" name="Rounded Rectangle 24"/>
+          <p:cNvSpPr/>
+          <p:nvPr/>
+        </p:nvSpPr>
+        <p:spPr>
+          <a:xfrm>
+            <a:off x="7882127" y="1883664"/>
+            <a:ext cx="3136392" cy="658368"/>
+          </a:xfrm>
+          <a:prstGeom prst="roundRect">
+            <a:avLst>
+              <a:gd name="adj" fmla="val 8000"/>
+            </a:avLst>
+          </a:prstGeom>
+          <a:solidFill>
+            <a:srgbClr val="EAF2FF"/>
+          </a:solidFill>
+          <a:ln>
+            <a:noFill/>
+          </a:ln>
+        </p:spPr>
+        <p:style>
+          <a:lnRef idx="1">
+            <a:schemeClr val="accent1"/>
+          </a:lnRef>
+          <a:fillRef idx="3">
+            <a:schemeClr val="accent1"/>
+          </a:fillRef>
+          <a:effectRef idx="2">
+            <a:schemeClr val="accent1"/>
+          </a:effectRef>
+          <a:fontRef idx="minor">
+            <a:schemeClr val="lt1"/>
+          </a:fontRef>
+        </p:style>
+        <p:txBody>
+          <a:bodyPr rtlCol="0" anchor="ctr"/>
+          <a:lstStyle/>
+          <a:p>
+            <a:pPr algn="ctr"/>
+          </a:p>
+        </p:txBody>
+      </p:sp>
+      <p:sp>
+        <p:nvSpPr>
+          <p:cNvPr id="26" name="TextBox 25"/>
+          <p:cNvSpPr txBox="1"/>
+          <p:nvPr/>
+        </p:nvSpPr>
+        <p:spPr>
+          <a:xfrm>
+            <a:off x="8010144" y="1883664"/>
+            <a:ext cx="2880360" cy="658368"/>
+          </a:xfrm>
+          <a:prstGeom prst="rect">
+            <a:avLst/>
+          </a:prstGeom>
+          <a:noFill/>
+        </p:spPr>
+        <p:txBody>
+          <a:bodyPr wrap="square" lIns="0" rIns="0" tIns="0" bIns="0" anchor="ctr">
+            <a:spAutoFit/>
+          </a:bodyPr>
+          <a:lstStyle/>
+          <a:p>
+            <a:pPr algn="ctr">
+              <a:lnSpc>
+                <a:spcPct val="100000"/>
+              </a:lnSpc>
+              <a:spcBef>
+                <a:spcPts val="0"/>
+              </a:spcBef>
+              <a:spcAft>
+                <a:spcPts val="0"/>
+              </a:spcAft>
+            </a:pPr>
+            <a:r>
+              <a:rPr sz="940" b="1">
+                <a:solidFill>
+                  <a:srgbClr val="026BFF"/>
+                </a:solidFill>
+                <a:latin typeface="Noto Sans CJK SC"/>
+              </a:rPr>
+              <a:t>规则或非结构网格 · 稀疏线性系统</a:t>
+            </a:r>
+          </a:p>
+        </p:txBody>
+      </p:sp>
+      <p:sp>
+        <p:nvSpPr>
+          <p:cNvPr id="27" name="Rounded Rectangle 26"/>
+          <p:cNvSpPr/>
+          <p:nvPr/>
+        </p:nvSpPr>
+        <p:spPr>
+          <a:xfrm>
+            <a:off x="4297680" y="2907792"/>
+            <a:ext cx="7040880" cy="1051560"/>
+          </a:xfrm>
+          <a:prstGeom prst="roundRect">
+            <a:avLst>
+              <a:gd name="adj" fmla="val 8000"/>
+            </a:avLst>
+          </a:prstGeom>
+          <a:solidFill>
+            <a:srgbClr val="FFFFFF"/>
+          </a:solidFill>
+          <a:ln w="12700">
+            <a:solidFill>
+              <a:srgbClr val="E4E9F2"/>
+            </a:solidFill>
+          </a:ln>
+        </p:spPr>
+        <p:style>
+          <a:lnRef idx="1">
+            <a:schemeClr val="accent1"/>
+          </a:lnRef>
+          <a:fillRef idx="3">
+            <a:schemeClr val="accent1"/>
+          </a:fillRef>
+          <a:effectRef idx="2">
+            <a:schemeClr val="accent1"/>
+          </a:effectRef>
+          <a:fontRef idx="minor">
+            <a:schemeClr val="lt1"/>
+          </a:fontRef>
+        </p:style>
+        <p:txBody>
+          <a:bodyPr rtlCol="0" anchor="ctr"/>
+          <a:lstStyle/>
+          <a:p>
+            <a:pPr algn="ctr"/>
+          </a:p>
+        </p:txBody>
+      </p:sp>
+      <p:sp>
+        <p:nvSpPr>
+          <p:cNvPr id="28" name="Rectangle 27"/>
+          <p:cNvSpPr/>
+          <p:nvPr/>
+        </p:nvSpPr>
+        <p:spPr>
+          <a:xfrm>
+            <a:off x="4526280" y="3136392"/>
+            <a:ext cx="566928" cy="566928"/>
+          </a:xfrm>
+          <a:prstGeom prst="rect">
+            <a:avLst/>
+          </a:prstGeom>
+          <a:solidFill>
+            <a:srgbClr val="24C58D"/>
+          </a:solidFill>
+          <a:ln>
+            <a:noFill/>
+          </a:ln>
+        </p:spPr>
+        <p:style>
+          <a:lnRef idx="1">
+            <a:schemeClr val="accent1"/>
+          </a:lnRef>
+          <a:fillRef idx="3">
+            <a:schemeClr val="accent1"/>
+          </a:fillRef>
+          <a:effectRef idx="2">
+            <a:schemeClr val="accent1"/>
+          </a:effectRef>
+          <a:fontRef idx="minor">
+            <a:schemeClr val="lt1"/>
+          </a:fontRef>
+        </p:style>
+        <p:txBody>
+          <a:bodyPr rtlCol="0" anchor="ctr"/>
+          <a:lstStyle/>
+          <a:p>
+            <a:pPr algn="ctr"/>
+          </a:p>
+        </p:txBody>
+      </p:sp>
+      <p:sp>
+        <p:nvSpPr>
+          <p:cNvPr id="29" name="TextBox 28"/>
+          <p:cNvSpPr txBox="1"/>
+          <p:nvPr/>
+        </p:nvSpPr>
+        <p:spPr>
+          <a:xfrm>
+            <a:off x="4526280" y="3136392"/>
+            <a:ext cx="566928" cy="566928"/>
+          </a:xfrm>
+          <a:prstGeom prst="rect">
+            <a:avLst/>
+          </a:prstGeom>
+          <a:noFill/>
+        </p:spPr>
+        <p:txBody>
+          <a:bodyPr wrap="square" lIns="0" rIns="0" tIns="0" bIns="0" anchor="ctr">
+            <a:spAutoFit/>
+          </a:bodyPr>
+          <a:lstStyle/>
+          <a:p>
+            <a:pPr algn="ctr">
+              <a:lnSpc>
+                <a:spcPct val="100000"/>
+              </a:lnSpc>
+              <a:spcBef>
+                <a:spcPts val="0"/>
+              </a:spcBef>
+              <a:spcAft>
+                <a:spcPts val="0"/>
+              </a:spcAft>
+            </a:pPr>
+            <a:r>
+              <a:rPr sz="1250" b="1">
+                <a:solidFill>
+                  <a:srgbClr val="FFFFFF"/>
+                </a:solidFill>
+                <a:latin typeface="Noto Sans CJK SC"/>
+              </a:rPr>
+              <a:t>02</a:t>
+            </a:r>
+          </a:p>
+        </p:txBody>
+      </p:sp>
+      <p:sp>
+        <p:nvSpPr>
+          <p:cNvPr id="30" name="TextBox 29"/>
+          <p:cNvSpPr txBox="1"/>
+          <p:nvPr/>
+        </p:nvSpPr>
+        <p:spPr>
+          <a:xfrm>
+            <a:off x="5330952" y="3026664"/>
+            <a:ext cx="2057400" cy="347472"/>
+          </a:xfrm>
+          <a:prstGeom prst="rect">
+            <a:avLst/>
+          </a:prstGeom>
+          <a:noFill/>
+        </p:spPr>
+        <p:txBody>
+          <a:bodyPr wrap="square" lIns="0" rIns="0" tIns="0" bIns="0" anchor="ctr">
+            <a:spAutoFit/>
+          </a:bodyPr>
+          <a:lstStyle/>
+          <a:p>
+            <a:pPr algn="l">
+              <a:lnSpc>
+                <a:spcPct val="100000"/>
+              </a:lnSpc>
+              <a:spcBef>
+                <a:spcPts val="0"/>
+              </a:spcBef>
+              <a:spcAft>
+                <a:spcPts val="0"/>
+              </a:spcAft>
+            </a:pPr>
+            <a:r>
+              <a:rPr sz="1450" b="1">
+                <a:solidFill>
+                  <a:srgbClr val="262626"/>
+                </a:solidFill>
+                <a:latin typeface="Noto Sans CJK SC"/>
+              </a:rPr>
+              <a:t>APIC / 粒子—网格</a:t>
+            </a:r>
+          </a:p>
+        </p:txBody>
+      </p:sp>
+      <p:sp>
+        <p:nvSpPr>
+          <p:cNvPr id="31" name="TextBox 30"/>
+          <p:cNvSpPr txBox="1"/>
+          <p:nvPr/>
+        </p:nvSpPr>
+        <p:spPr>
+          <a:xfrm>
+            <a:off x="5330952" y="3374136"/>
+            <a:ext cx="2240280" cy="448056"/>
+          </a:xfrm>
+          <a:prstGeom prst="rect">
+            <a:avLst/>
+          </a:prstGeom>
+          <a:noFill/>
+        </p:spPr>
+        <p:txBody>
+          <a:bodyPr wrap="square" lIns="0" rIns="0" tIns="0" bIns="0" anchor="ctr">
+            <a:spAutoFit/>
+          </a:bodyPr>
+          <a:lstStyle/>
+          <a:p>
+            <a:pPr algn="l">
+              <a:lnSpc>
+                <a:spcPct val="100000"/>
+              </a:lnSpc>
+              <a:spcBef>
+                <a:spcPts val="0"/>
+              </a:spcBef>
+              <a:spcAft>
+                <a:spcPts val="0"/>
+              </a:spcAft>
+            </a:pPr>
+            <a:r>
+              <a:rPr sz="950" b="0">
+                <a:solidFill>
+                  <a:srgbClr val="727171"/>
+                </a:solidFill>
+                <a:latin typeface="Noto Sans CJK SC"/>
+              </a:rPr>
+              <a:t>粒子携带状态
+网格完成力与压力更新</a:t>
+            </a:r>
+          </a:p>
+        </p:txBody>
+      </p:sp>
+      <p:sp>
+        <p:nvSpPr>
+          <p:cNvPr id="32" name="Rounded Rectangle 31"/>
+          <p:cNvSpPr/>
+          <p:nvPr/>
+        </p:nvSpPr>
+        <p:spPr>
+          <a:xfrm>
+            <a:off x="7882127" y="3108960"/>
+            <a:ext cx="3136392" cy="658368"/>
+          </a:xfrm>
+          <a:prstGeom prst="roundRect">
+            <a:avLst>
+              <a:gd name="adj" fmla="val 8000"/>
+            </a:avLst>
+          </a:prstGeom>
+          <a:solidFill>
+            <a:srgbClr val="E7F8F1"/>
+          </a:solidFill>
+          <a:ln>
+            <a:noFill/>
+          </a:ln>
+        </p:spPr>
+        <p:style>
+          <a:lnRef idx="1">
+            <a:schemeClr val="accent1"/>
+          </a:lnRef>
+          <a:fillRef idx="3">
+            <a:schemeClr val="accent1"/>
+          </a:fillRef>
+          <a:effectRef idx="2">
+            <a:schemeClr val="accent1"/>
+          </a:effectRef>
+          <a:fontRef idx="minor">
+            <a:schemeClr val="lt1"/>
+          </a:fontRef>
+        </p:style>
+        <p:txBody>
+          <a:bodyPr rtlCol="0" anchor="ctr"/>
+          <a:lstStyle/>
+          <a:p>
+            <a:pPr algn="ctr"/>
+          </a:p>
+        </p:txBody>
+      </p:sp>
+      <p:sp>
+        <p:nvSpPr>
+          <p:cNvPr id="33" name="TextBox 32"/>
+          <p:cNvSpPr txBox="1"/>
+          <p:nvPr/>
+        </p:nvSpPr>
+        <p:spPr>
+          <a:xfrm>
+            <a:off x="8010144" y="3108960"/>
+            <a:ext cx="2880360" cy="658368"/>
+          </a:xfrm>
+          <a:prstGeom prst="rect">
+            <a:avLst/>
+          </a:prstGeom>
+          <a:noFill/>
+        </p:spPr>
+        <p:txBody>
+          <a:bodyPr wrap="square" lIns="0" rIns="0" tIns="0" bIns="0" anchor="ctr">
+            <a:spAutoFit/>
+          </a:bodyPr>
+          <a:lstStyle/>
+          <a:p>
+            <a:pPr algn="ctr">
+              <a:lnSpc>
+                <a:spcPct val="100000"/>
+              </a:lnSpc>
+              <a:spcBef>
+                <a:spcPts val="0"/>
+              </a:spcBef>
+              <a:spcAft>
+                <a:spcPts val="0"/>
+              </a:spcAft>
+            </a:pPr>
+            <a:r>
+              <a:rPr sz="940" b="1">
+                <a:solidFill>
+                  <a:srgbClr val="24C58D"/>
+                </a:solidFill>
+                <a:latin typeface="Noto Sans CJK SC"/>
+              </a:rPr>
+              <a:t>适合大变形、自由表面和运动界面</a:t>
+            </a:r>
+          </a:p>
+        </p:txBody>
+      </p:sp>
+      <p:sp>
+        <p:nvSpPr>
+          <p:cNvPr id="34" name="Rounded Rectangle 33"/>
+          <p:cNvSpPr/>
+          <p:nvPr/>
+        </p:nvSpPr>
+        <p:spPr>
+          <a:xfrm>
+            <a:off x="4297680" y="4133088"/>
+            <a:ext cx="7040880" cy="1051560"/>
+          </a:xfrm>
+          <a:prstGeom prst="roundRect">
+            <a:avLst>
+              <a:gd name="adj" fmla="val 8000"/>
+            </a:avLst>
+          </a:prstGeom>
+          <a:solidFill>
+            <a:srgbClr val="FFFFFF"/>
+          </a:solidFill>
+          <a:ln w="12700">
+            <a:solidFill>
+              <a:srgbClr val="E4E9F2"/>
+            </a:solidFill>
+          </a:ln>
+        </p:spPr>
+        <p:style>
+          <a:lnRef idx="1">
+            <a:schemeClr val="accent1"/>
+          </a:lnRef>
+          <a:fillRef idx="3">
+            <a:schemeClr val="accent1"/>
+          </a:fillRef>
+          <a:effectRef idx="2">
+            <a:schemeClr val="accent1"/>
+          </a:effectRef>
+          <a:fontRef idx="minor">
+            <a:schemeClr val="lt1"/>
+          </a:fontRef>
+        </p:style>
+        <p:txBody>
+          <a:bodyPr rtlCol="0" anchor="ctr"/>
+          <a:lstStyle/>
+          <a:p>
+            <a:pPr algn="ctr"/>
+          </a:p>
+        </p:txBody>
+      </p:sp>
+      <p:sp>
+        <p:nvSpPr>
+          <p:cNvPr id="35" name="Rectangle 34"/>
+          <p:cNvSpPr/>
+          <p:nvPr/>
+        </p:nvSpPr>
+        <p:spPr>
+          <a:xfrm>
+            <a:off x="4526280" y="4361688"/>
+            <a:ext cx="566928" cy="566928"/>
+          </a:xfrm>
+          <a:prstGeom prst="rect">
+            <a:avLst/>
+          </a:prstGeom>
+          <a:solidFill>
+            <a:srgbClr val="926DE5"/>
+          </a:solidFill>
+          <a:ln>
+            <a:noFill/>
+          </a:ln>
+        </p:spPr>
+        <p:style>
+          <a:lnRef idx="1">
+            <a:schemeClr val="accent1"/>
+          </a:lnRef>
+          <a:fillRef idx="3">
+            <a:schemeClr val="accent1"/>
+          </a:fillRef>
+          <a:effectRef idx="2">
+            <a:schemeClr val="accent1"/>
+          </a:effectRef>
+          <a:fontRef idx="minor">
+            <a:schemeClr val="lt1"/>
+          </a:fontRef>
+        </p:style>
+        <p:txBody>
+          <a:bodyPr rtlCol="0" anchor="ctr"/>
+          <a:lstStyle/>
+          <a:p>
+            <a:pPr algn="ctr"/>
+          </a:p>
+        </p:txBody>
+      </p:sp>
+      <p:sp>
+        <p:nvSpPr>
+          <p:cNvPr id="36" name="TextBox 35"/>
+          <p:cNvSpPr txBox="1"/>
+          <p:nvPr/>
+        </p:nvSpPr>
+        <p:spPr>
+          <a:xfrm>
+            <a:off x="4526280" y="4361688"/>
+            <a:ext cx="566928" cy="566928"/>
+          </a:xfrm>
+          <a:prstGeom prst="rect">
+            <a:avLst/>
+          </a:prstGeom>
+          <a:noFill/>
+        </p:spPr>
+        <p:txBody>
+          <a:bodyPr wrap="square" lIns="0" rIns="0" tIns="0" bIns="0" anchor="ctr">
+            <a:spAutoFit/>
+          </a:bodyPr>
+          <a:lstStyle/>
+          <a:p>
+            <a:pPr algn="ctr">
+              <a:lnSpc>
+                <a:spcPct val="100000"/>
+              </a:lnSpc>
+              <a:spcBef>
+                <a:spcPts val="0"/>
+              </a:spcBef>
+              <a:spcAft>
+                <a:spcPts val="0"/>
+              </a:spcAft>
+            </a:pPr>
+            <a:r>
+              <a:rPr sz="1250" b="1">
+                <a:solidFill>
+                  <a:srgbClr val="FFFFFF"/>
+                </a:solidFill>
+                <a:latin typeface="Noto Sans CJK SC"/>
+              </a:rPr>
+              <a:t>03</a:t>
+            </a:r>
+          </a:p>
+        </p:txBody>
+      </p:sp>
+      <p:sp>
+        <p:nvSpPr>
+          <p:cNvPr id="37" name="TextBox 36"/>
+          <p:cNvSpPr txBox="1"/>
+          <p:nvPr/>
+        </p:nvSpPr>
+        <p:spPr>
+          <a:xfrm>
+            <a:off x="5330952" y="4251960"/>
+            <a:ext cx="2057400" cy="347472"/>
+          </a:xfrm>
+          <a:prstGeom prst="rect">
+            <a:avLst/>
+          </a:prstGeom>
+          <a:noFill/>
+        </p:spPr>
+        <p:txBody>
+          <a:bodyPr wrap="square" lIns="0" rIns="0" tIns="0" bIns="0" anchor="ctr">
+            <a:spAutoFit/>
+          </a:bodyPr>
+          <a:lstStyle/>
+          <a:p>
+            <a:pPr algn="l">
+              <a:lnSpc>
+                <a:spcPct val="100000"/>
+              </a:lnSpc>
+              <a:spcBef>
+                <a:spcPts val="0"/>
+              </a:spcBef>
+              <a:spcAft>
+                <a:spcPts val="0"/>
+              </a:spcAft>
+            </a:pPr>
+            <a:r>
+              <a:rPr sz="1450" b="1">
+                <a:solidFill>
+                  <a:srgbClr val="262626"/>
+                </a:solidFill>
+                <a:latin typeface="Noto Sans CJK SC"/>
+              </a:rPr>
+              <a:t>自定义 GPU Kernel</a:t>
+            </a:r>
+          </a:p>
+        </p:txBody>
+      </p:sp>
+      <p:sp>
+        <p:nvSpPr>
+          <p:cNvPr id="38" name="TextBox 37"/>
+          <p:cNvSpPr txBox="1"/>
+          <p:nvPr/>
+        </p:nvSpPr>
+        <p:spPr>
+          <a:xfrm>
+            <a:off x="5330952" y="4599432"/>
+            <a:ext cx="2240280" cy="448056"/>
+          </a:xfrm>
+          <a:prstGeom prst="rect">
+            <a:avLst/>
+          </a:prstGeom>
+          <a:noFill/>
+        </p:spPr>
+        <p:txBody>
+          <a:bodyPr wrap="square" lIns="0" rIns="0" tIns="0" bIns="0" anchor="ctr">
+            <a:spAutoFit/>
+          </a:bodyPr>
+          <a:lstStyle/>
+          <a:p>
+            <a:pPr algn="l">
+              <a:lnSpc>
+                <a:spcPct val="100000"/>
+              </a:lnSpc>
+              <a:spcBef>
+                <a:spcPts val="0"/>
+              </a:spcBef>
+              <a:spcAft>
+                <a:spcPts val="0"/>
+              </a:spcAft>
+            </a:pPr>
+            <a:r>
+              <a:rPr sz="950" b="0">
+                <a:solidFill>
+                  <a:srgbClr val="727171"/>
+                </a:solidFill>
+                <a:latin typeface="Noto Sans CJK SC"/>
+              </a:rPr>
+              <a:t>SPH / 邻域查询
+通量、源项与边界更新</a:t>
+            </a:r>
+          </a:p>
+        </p:txBody>
+      </p:sp>
+      <p:sp>
+        <p:nvSpPr>
+          <p:cNvPr id="39" name="Rounded Rectangle 38"/>
+          <p:cNvSpPr/>
+          <p:nvPr/>
+        </p:nvSpPr>
+        <p:spPr>
+          <a:xfrm>
+            <a:off x="7882127" y="4334256"/>
+            <a:ext cx="3136392" cy="658368"/>
+          </a:xfrm>
+          <a:prstGeom prst="roundRect">
+            <a:avLst>
+              <a:gd name="adj" fmla="val 8000"/>
+            </a:avLst>
+          </a:prstGeom>
+          <a:solidFill>
+            <a:srgbClr val="F2EDFC"/>
+          </a:solidFill>
+          <a:ln>
+            <a:noFill/>
+          </a:ln>
+        </p:spPr>
+        <p:style>
+          <a:lnRef idx="1">
+            <a:schemeClr val="accent1"/>
+          </a:lnRef>
+          <a:fillRef idx="3">
+            <a:schemeClr val="accent1"/>
+          </a:fillRef>
+          <a:effectRef idx="2">
+            <a:schemeClr val="accent1"/>
+          </a:effectRef>
+          <a:fontRef idx="minor">
+            <a:schemeClr val="lt1"/>
+          </a:fontRef>
+        </p:style>
+        <p:txBody>
+          <a:bodyPr rtlCol="0" anchor="ctr"/>
+          <a:lstStyle/>
+          <a:p>
+            <a:pPr algn="ctr"/>
+          </a:p>
+        </p:txBody>
+      </p:sp>
+      <p:sp>
+        <p:nvSpPr>
+          <p:cNvPr id="40" name="TextBox 39"/>
+          <p:cNvSpPr txBox="1"/>
+          <p:nvPr/>
+        </p:nvSpPr>
+        <p:spPr>
+          <a:xfrm>
+            <a:off x="8010144" y="4334256"/>
+            <a:ext cx="2880360" cy="658368"/>
+          </a:xfrm>
+          <a:prstGeom prst="rect">
+            <a:avLst/>
+          </a:prstGeom>
+          <a:noFill/>
+        </p:spPr>
+        <p:txBody>
+          <a:bodyPr wrap="square" lIns="0" rIns="0" tIns="0" bIns="0" anchor="ctr">
+            <a:spAutoFit/>
+          </a:bodyPr>
+          <a:lstStyle/>
+          <a:p>
+            <a:pPr algn="ctr">
+              <a:lnSpc>
+                <a:spcPct val="100000"/>
+              </a:lnSpc>
+              <a:spcBef>
+                <a:spcPts val="0"/>
+              </a:spcBef>
+              <a:spcAft>
+                <a:spcPts val="0"/>
+              </a:spcAft>
+            </a:pPr>
+            <a:r>
+              <a:rPr sz="940" b="1">
+                <a:solidFill>
+                  <a:srgbClr val="926DE5"/>
+                </a:solidFill>
+                <a:latin typeface="Noto Sans CJK SC"/>
+              </a:rPr>
+              <a:t>适合高度并行的专用流体模型</a:t>
+            </a:r>
+          </a:p>
+        </p:txBody>
+      </p:sp>
+      <p:sp>
+        <p:nvSpPr>
+          <p:cNvPr id="41" name="Rounded Rectangle 40"/>
+          <p:cNvSpPr/>
+          <p:nvPr/>
+        </p:nvSpPr>
+        <p:spPr>
+          <a:xfrm>
+            <a:off x="4297680" y="5440680"/>
+            <a:ext cx="7040880" cy="557784"/>
+          </a:xfrm>
+          <a:prstGeom prst="roundRect">
+            <a:avLst>
+              <a:gd name="adj" fmla="val 8000"/>
+            </a:avLst>
+          </a:prstGeom>
+          <a:solidFill>
+            <a:srgbClr val="FDEEE0"/>
+          </a:solidFill>
+          <a:ln>
+            <a:noFill/>
+          </a:ln>
+        </p:spPr>
+        <p:style>
+          <a:lnRef idx="1">
+            <a:schemeClr val="accent1"/>
+          </a:lnRef>
+          <a:fillRef idx="3">
+            <a:schemeClr val="accent1"/>
+          </a:fillRef>
+          <a:effectRef idx="2">
+            <a:schemeClr val="accent1"/>
+          </a:effectRef>
+          <a:fontRef idx="minor">
+            <a:schemeClr val="lt1"/>
+          </a:fontRef>
+        </p:style>
+        <p:txBody>
+          <a:bodyPr rtlCol="0" anchor="ctr"/>
+          <a:lstStyle/>
+          <a:p>
+            <a:pPr algn="ctr"/>
+          </a:p>
+        </p:txBody>
+      </p:sp>
+      <p:sp>
+        <p:nvSpPr>
+          <p:cNvPr id="42" name="Oval 41"/>
+          <p:cNvSpPr/>
+          <p:nvPr/>
+        </p:nvSpPr>
+        <p:spPr>
+          <a:xfrm>
+            <a:off x="4535424" y="5568696"/>
+            <a:ext cx="292608" cy="292608"/>
+          </a:xfrm>
+          <a:prstGeom prst="ellipse">
+            <a:avLst/>
+          </a:prstGeom>
+          <a:solidFill>
+            <a:srgbClr val="F68941"/>
+          </a:solidFill>
+          <a:ln>
+            <a:noFill/>
+          </a:ln>
+        </p:spPr>
+        <p:style>
+          <a:lnRef idx="1">
+            <a:schemeClr val="accent1"/>
+          </a:lnRef>
+          <a:fillRef idx="3">
+            <a:schemeClr val="accent1"/>
+          </a:fillRef>
+          <a:effectRef idx="2">
+            <a:schemeClr val="accent1"/>
+          </a:effectRef>
+          <a:fontRef idx="minor">
+            <a:schemeClr val="lt1"/>
+          </a:fontRef>
+        </p:style>
+        <p:txBody>
+          <a:bodyPr rtlCol="0" anchor="ctr"/>
+          <a:lstStyle/>
+          <a:p>
+            <a:pPr algn="ctr"/>
+          </a:p>
+        </p:txBody>
+      </p:sp>
+      <p:sp>
+        <p:nvSpPr>
+          <p:cNvPr id="43" name="TextBox 42"/>
+          <p:cNvSpPr txBox="1"/>
+          <p:nvPr/>
+        </p:nvSpPr>
+        <p:spPr>
+          <a:xfrm>
+            <a:off x="4535424" y="5568696"/>
+            <a:ext cx="292608" cy="292608"/>
+          </a:xfrm>
+          <a:prstGeom prst="rect">
+            <a:avLst/>
+          </a:prstGeom>
+          <a:noFill/>
+        </p:spPr>
+        <p:txBody>
+          <a:bodyPr wrap="square" lIns="0" rIns="0" tIns="0" bIns="0" anchor="ctr">
+            <a:spAutoFit/>
+          </a:bodyPr>
+          <a:lstStyle/>
+          <a:p>
+            <a:pPr algn="ctr">
+              <a:lnSpc>
+                <a:spcPct val="100000"/>
+              </a:lnSpc>
+              <a:spcBef>
+                <a:spcPts val="0"/>
+              </a:spcBef>
+              <a:spcAft>
+                <a:spcPts val="0"/>
+              </a:spcAft>
+            </a:pPr>
+            <a:r>
+              <a:rPr sz="780" b="1">
+                <a:solidFill>
+                  <a:srgbClr val="FFFFFF"/>
+                </a:solidFill>
+                <a:latin typeface="Noto Sans CJK SC"/>
+              </a:rPr>
+              <a:t>1</a:t>
+            </a:r>
+          </a:p>
+        </p:txBody>
+      </p:sp>
+      <p:sp>
+        <p:nvSpPr>
+          <p:cNvPr id="44" name="TextBox 43"/>
+          <p:cNvSpPr txBox="1"/>
+          <p:nvPr/>
+        </p:nvSpPr>
+        <p:spPr>
+          <a:xfrm>
+            <a:off x="4937760" y="5440680"/>
+            <a:ext cx="822960" cy="274320"/>
+          </a:xfrm>
+          <a:prstGeom prst="rect">
+            <a:avLst/>
+          </a:prstGeom>
+          <a:noFill/>
+        </p:spPr>
+        <p:txBody>
+          <a:bodyPr wrap="square" lIns="0" rIns="0" tIns="0" bIns="0" anchor="ctr">
+            <a:spAutoFit/>
+          </a:bodyPr>
+          <a:lstStyle/>
+          <a:p>
+            <a:pPr algn="l">
+              <a:lnSpc>
+                <a:spcPct val="100000"/>
+              </a:lnSpc>
+              <a:spcBef>
+                <a:spcPts val="0"/>
+              </a:spcBef>
+              <a:spcAft>
+                <a:spcPts val="0"/>
+              </a:spcAft>
+            </a:pPr>
+            <a:r>
+              <a:rPr sz="980" b="1">
+                <a:solidFill>
+                  <a:srgbClr val="262626"/>
+                </a:solidFill>
+                <a:latin typeface="Noto Sans CJK SC"/>
+              </a:rPr>
+              <a:t>熔池流动</a:t>
+            </a:r>
+          </a:p>
+        </p:txBody>
+      </p:sp>
+      <p:sp>
+        <p:nvSpPr>
+          <p:cNvPr id="45" name="TextBox 44"/>
+          <p:cNvSpPr txBox="1"/>
+          <p:nvPr/>
+        </p:nvSpPr>
+        <p:spPr>
+          <a:xfrm>
+            <a:off x="5705856" y="5440680"/>
+            <a:ext cx="850392" cy="274320"/>
+          </a:xfrm>
+          <a:prstGeom prst="rect">
+            <a:avLst/>
+          </a:prstGeom>
+          <a:noFill/>
+        </p:spPr>
+        <p:txBody>
+          <a:bodyPr wrap="square" lIns="0" rIns="0" tIns="0" bIns="0" anchor="ctr">
+            <a:spAutoFit/>
+          </a:bodyPr>
+          <a:lstStyle/>
+          <a:p>
+            <a:pPr algn="r">
+              <a:lnSpc>
+                <a:spcPct val="100000"/>
+              </a:lnSpc>
+              <a:spcBef>
+                <a:spcPts val="0"/>
+              </a:spcBef>
+              <a:spcAft>
+                <a:spcPts val="0"/>
+              </a:spcAft>
+            </a:pPr>
+            <a:r>
+              <a:rPr sz="830" b="0">
+                <a:solidFill>
+                  <a:srgbClr val="727171"/>
+                </a:solidFill>
+                <a:latin typeface="Noto Sans CJK SC"/>
+              </a:rPr>
+              <a:t>表面张力 / 浮力</a:t>
+            </a:r>
+          </a:p>
+        </p:txBody>
+      </p:sp>
+      <p:sp>
+        <p:nvSpPr>
+          <p:cNvPr id="46" name="Oval 45"/>
+          <p:cNvSpPr/>
+          <p:nvPr/>
+        </p:nvSpPr>
+        <p:spPr>
+          <a:xfrm>
+            <a:off x="6748272" y="5568696"/>
+            <a:ext cx="292608" cy="292608"/>
+          </a:xfrm>
+          <a:prstGeom prst="ellipse">
+            <a:avLst/>
+          </a:prstGeom>
+          <a:solidFill>
+            <a:srgbClr val="F68941"/>
+          </a:solidFill>
+          <a:ln>
+            <a:noFill/>
+          </a:ln>
+        </p:spPr>
+        <p:style>
+          <a:lnRef idx="1">
+            <a:schemeClr val="accent1"/>
+          </a:lnRef>
+          <a:fillRef idx="3">
+            <a:schemeClr val="accent1"/>
+          </a:fillRef>
+          <a:effectRef idx="2">
+            <a:schemeClr val="accent1"/>
+          </a:effectRef>
+          <a:fontRef idx="minor">
+            <a:schemeClr val="lt1"/>
+          </a:fontRef>
+        </p:style>
+        <p:txBody>
+          <a:bodyPr rtlCol="0" anchor="ctr"/>
+          <a:lstStyle/>
+          <a:p>
+            <a:pPr algn="ctr"/>
+          </a:p>
+        </p:txBody>
+      </p:sp>
+      <p:sp>
+        <p:nvSpPr>
+          <p:cNvPr id="47" name="TextBox 46"/>
+          <p:cNvSpPr txBox="1"/>
+          <p:nvPr/>
+        </p:nvSpPr>
+        <p:spPr>
+          <a:xfrm>
+            <a:off x="6748272" y="5568696"/>
+            <a:ext cx="292608" cy="292608"/>
+          </a:xfrm>
+          <a:prstGeom prst="rect">
+            <a:avLst/>
+          </a:prstGeom>
+          <a:noFill/>
+        </p:spPr>
+        <p:txBody>
+          <a:bodyPr wrap="square" lIns="0" rIns="0" tIns="0" bIns="0" anchor="ctr">
+            <a:spAutoFit/>
+          </a:bodyPr>
+          <a:lstStyle/>
+          <a:p>
+            <a:pPr algn="ctr">
+              <a:lnSpc>
+                <a:spcPct val="100000"/>
+              </a:lnSpc>
+              <a:spcBef>
+                <a:spcPts val="0"/>
+              </a:spcBef>
+              <a:spcAft>
+                <a:spcPts val="0"/>
+              </a:spcAft>
+            </a:pPr>
+            <a:r>
+              <a:rPr sz="780" b="1">
+                <a:solidFill>
+                  <a:srgbClr val="FFFFFF"/>
+                </a:solidFill>
+                <a:latin typeface="Noto Sans CJK SC"/>
+              </a:rPr>
+              <a:t>2</a:t>
+            </a:r>
+          </a:p>
+        </p:txBody>
+      </p:sp>
+      <p:sp>
+        <p:nvSpPr>
+          <p:cNvPr id="48" name="TextBox 47"/>
+          <p:cNvSpPr txBox="1"/>
+          <p:nvPr/>
+        </p:nvSpPr>
+        <p:spPr>
+          <a:xfrm>
+            <a:off x="7150608" y="5440680"/>
+            <a:ext cx="822960" cy="274320"/>
+          </a:xfrm>
+          <a:prstGeom prst="rect">
+            <a:avLst/>
+          </a:prstGeom>
+          <a:noFill/>
+        </p:spPr>
+        <p:txBody>
+          <a:bodyPr wrap="square" lIns="0" rIns="0" tIns="0" bIns="0" anchor="ctr">
+            <a:spAutoFit/>
+          </a:bodyPr>
+          <a:lstStyle/>
+          <a:p>
+            <a:pPr algn="l">
+              <a:lnSpc>
+                <a:spcPct val="100000"/>
+              </a:lnSpc>
+              <a:spcBef>
+                <a:spcPts val="0"/>
+              </a:spcBef>
+              <a:spcAft>
+                <a:spcPts val="0"/>
+              </a:spcAft>
+            </a:pPr>
+            <a:r>
+              <a:rPr sz="980" b="1">
+                <a:solidFill>
+                  <a:srgbClr val="262626"/>
+                </a:solidFill>
+                <a:latin typeface="Noto Sans CJK SC"/>
+              </a:rPr>
+              <a:t>保护气体</a:t>
+            </a:r>
+          </a:p>
+        </p:txBody>
+      </p:sp>
+      <p:sp>
+        <p:nvSpPr>
+          <p:cNvPr id="49" name="TextBox 48"/>
+          <p:cNvSpPr txBox="1"/>
+          <p:nvPr/>
+        </p:nvSpPr>
+        <p:spPr>
+          <a:xfrm>
+            <a:off x="7918704" y="5440680"/>
+            <a:ext cx="850392" cy="274320"/>
+          </a:xfrm>
+          <a:prstGeom prst="rect">
+            <a:avLst/>
+          </a:prstGeom>
+          <a:noFill/>
+        </p:spPr>
+        <p:txBody>
+          <a:bodyPr wrap="square" lIns="0" rIns="0" tIns="0" bIns="0" anchor="ctr">
+            <a:spAutoFit/>
+          </a:bodyPr>
+          <a:lstStyle/>
+          <a:p>
+            <a:pPr algn="r">
+              <a:lnSpc>
+                <a:spcPct val="100000"/>
+              </a:lnSpc>
+              <a:spcBef>
+                <a:spcPts val="0"/>
+              </a:spcBef>
+              <a:spcAft>
+                <a:spcPts val="0"/>
+              </a:spcAft>
+            </a:pPr>
+            <a:r>
+              <a:rPr sz="830" b="0">
+                <a:solidFill>
+                  <a:srgbClr val="727171"/>
+                </a:solidFill>
+                <a:latin typeface="Noto Sans CJK SC"/>
+              </a:rPr>
+              <a:t>喷流 / 卷吸</a:t>
+            </a:r>
+          </a:p>
+        </p:txBody>
+      </p:sp>
+      <p:sp>
+        <p:nvSpPr>
+          <p:cNvPr id="50" name="Oval 49"/>
+          <p:cNvSpPr/>
+          <p:nvPr/>
+        </p:nvSpPr>
+        <p:spPr>
+          <a:xfrm>
+            <a:off x="8961120" y="5568696"/>
+            <a:ext cx="292608" cy="292608"/>
+          </a:xfrm>
+          <a:prstGeom prst="ellipse">
+            <a:avLst/>
+          </a:prstGeom>
+          <a:solidFill>
+            <a:srgbClr val="F68941"/>
+          </a:solidFill>
+          <a:ln>
+            <a:noFill/>
+          </a:ln>
+        </p:spPr>
+        <p:style>
+          <a:lnRef idx="1">
+            <a:schemeClr val="accent1"/>
+          </a:lnRef>
+          <a:fillRef idx="3">
+            <a:schemeClr val="accent1"/>
+          </a:fillRef>
+          <a:effectRef idx="2">
+            <a:schemeClr val="accent1"/>
+          </a:effectRef>
+          <a:fontRef idx="minor">
+            <a:schemeClr val="lt1"/>
+          </a:fontRef>
+        </p:style>
+        <p:txBody>
+          <a:bodyPr rtlCol="0" anchor="ctr"/>
+          <a:lstStyle/>
+          <a:p>
+            <a:pPr algn="ctr"/>
+          </a:p>
+        </p:txBody>
+      </p:sp>
+      <p:sp>
+        <p:nvSpPr>
+          <p:cNvPr id="51" name="TextBox 50"/>
+          <p:cNvSpPr txBox="1"/>
+          <p:nvPr/>
+        </p:nvSpPr>
+        <p:spPr>
+          <a:xfrm>
+            <a:off x="8961120" y="5568696"/>
+            <a:ext cx="292608" cy="292608"/>
+          </a:xfrm>
+          <a:prstGeom prst="rect">
+            <a:avLst/>
+          </a:prstGeom>
+          <a:noFill/>
+        </p:spPr>
+        <p:txBody>
+          <a:bodyPr wrap="square" lIns="0" rIns="0" tIns="0" bIns="0" anchor="ctr">
+            <a:spAutoFit/>
+          </a:bodyPr>
+          <a:lstStyle/>
+          <a:p>
+            <a:pPr algn="ctr">
+              <a:lnSpc>
+                <a:spcPct val="100000"/>
+              </a:lnSpc>
+              <a:spcBef>
+                <a:spcPts val="0"/>
+              </a:spcBef>
+              <a:spcAft>
+                <a:spcPts val="0"/>
+              </a:spcAft>
+            </a:pPr>
+            <a:r>
+              <a:rPr sz="780" b="1">
+                <a:solidFill>
+                  <a:srgbClr val="FFFFFF"/>
+                </a:solidFill>
+                <a:latin typeface="Noto Sans CJK SC"/>
+              </a:rPr>
+              <a:t>3</a:t>
+            </a:r>
+          </a:p>
+        </p:txBody>
+      </p:sp>
+      <p:sp>
+        <p:nvSpPr>
+          <p:cNvPr id="52" name="TextBox 51"/>
+          <p:cNvSpPr txBox="1"/>
+          <p:nvPr/>
+        </p:nvSpPr>
+        <p:spPr>
+          <a:xfrm>
+            <a:off x="9363456" y="5440680"/>
+            <a:ext cx="822960" cy="274320"/>
+          </a:xfrm>
+          <a:prstGeom prst="rect">
+            <a:avLst/>
+          </a:prstGeom>
+          <a:noFill/>
+        </p:spPr>
+        <p:txBody>
+          <a:bodyPr wrap="square" lIns="0" rIns="0" tIns="0" bIns="0" anchor="ctr">
+            <a:spAutoFit/>
+          </a:bodyPr>
+          <a:lstStyle/>
+          <a:p>
+            <a:pPr algn="l">
+              <a:lnSpc>
+                <a:spcPct val="100000"/>
+              </a:lnSpc>
+              <a:spcBef>
+                <a:spcPts val="0"/>
+              </a:spcBef>
+              <a:spcAft>
+                <a:spcPts val="0"/>
+              </a:spcAft>
+            </a:pPr>
+            <a:r>
+              <a:rPr sz="980" b="1">
+                <a:solidFill>
+                  <a:srgbClr val="262626"/>
+                </a:solidFill>
+                <a:latin typeface="Noto Sans CJK SC"/>
+              </a:rPr>
+              <a:t>热—流耦合</a:t>
+            </a:r>
+          </a:p>
+        </p:txBody>
+      </p:sp>
+      <p:sp>
+        <p:nvSpPr>
+          <p:cNvPr id="53" name="TextBox 52"/>
+          <p:cNvSpPr txBox="1"/>
+          <p:nvPr/>
+        </p:nvSpPr>
+        <p:spPr>
+          <a:xfrm>
+            <a:off x="10131552" y="5440680"/>
+            <a:ext cx="850392" cy="274320"/>
+          </a:xfrm>
+          <a:prstGeom prst="rect">
+            <a:avLst/>
+          </a:prstGeom>
+          <a:noFill/>
+        </p:spPr>
+        <p:txBody>
+          <a:bodyPr wrap="square" lIns="0" rIns="0" tIns="0" bIns="0" anchor="ctr">
+            <a:spAutoFit/>
+          </a:bodyPr>
+          <a:lstStyle/>
+          <a:p>
+            <a:pPr algn="r">
+              <a:lnSpc>
+                <a:spcPct val="100000"/>
+              </a:lnSpc>
+              <a:spcBef>
+                <a:spcPts val="0"/>
+              </a:spcBef>
+              <a:spcAft>
+                <a:spcPts val="0"/>
+              </a:spcAft>
+            </a:pPr>
+            <a:r>
+              <a:rPr sz="830" b="0">
+                <a:solidFill>
+                  <a:srgbClr val="727171"/>
+                </a:solidFill>
+                <a:latin typeface="Noto Sans CJK SC"/>
+              </a:rPr>
+              <a:t>温度—黏度—流速</a:t>
+            </a:r>
+          </a:p>
+        </p:txBody>
+      </p:sp>
+      <p:sp>
+        <p:nvSpPr>
+          <p:cNvPr id="54" name="TextBox 53"/>
+          <p:cNvSpPr txBox="1"/>
+          <p:nvPr/>
+        </p:nvSpPr>
+        <p:spPr>
+          <a:xfrm>
+            <a:off x="822960" y="6199632"/>
+            <a:ext cx="10515600" cy="164592"/>
+          </a:xfrm>
+          <a:prstGeom prst="rect">
+            <a:avLst/>
+          </a:prstGeom>
+          <a:noFill/>
+        </p:spPr>
+        <p:txBody>
+          <a:bodyPr wrap="square" lIns="0" rIns="0" tIns="0" bIns="0" anchor="ctr">
+            <a:spAutoFit/>
+          </a:bodyPr>
+          <a:lstStyle/>
+          <a:p>
+            <a:pPr algn="l">
+              <a:lnSpc>
+                <a:spcPct val="100000"/>
+              </a:lnSpc>
+              <a:spcBef>
+                <a:spcPts val="0"/>
+              </a:spcBef>
+              <a:spcAft>
+                <a:spcPts val="0"/>
+              </a:spcAft>
+            </a:pPr>
+            <a:r>
+              <a:rPr sz="720" b="0">
+                <a:solidFill>
+                  <a:srgbClr val="8B95A5"/>
+                </a:solidFill>
+                <a:latin typeface="Noto Sans CJK SC"/>
+              </a:rPr>
+              <a:t>依据 NVIDIA Warp 文档：warp.fem 提供 Stokes、Navier–Stokes 与 APIC 示例；湍流、多相与熔池自由表面模型需专项验证。</a:t>
+            </a:r>
+          </a:p>
+        </p:txBody>
+      </p:sp>
+      <p:sp>
+        <p:nvSpPr>
+          <p:cNvPr id="55" name="TextBox 54"/>
+          <p:cNvSpPr txBox="1"/>
+          <p:nvPr/>
+        </p:nvSpPr>
+        <p:spPr>
+          <a:xfrm>
+            <a:off x="822960" y="6510528"/>
+            <a:ext cx="3657600" cy="164592"/>
+          </a:xfrm>
+          <a:prstGeom prst="rect">
+            <a:avLst/>
+          </a:prstGeom>
+          <a:noFill/>
+        </p:spPr>
+        <p:txBody>
+          <a:bodyPr wrap="square" lIns="0" rIns="0" tIns="0" bIns="0" anchor="b">
+            <a:spAutoFit/>
+          </a:bodyPr>
+          <a:lstStyle/>
+          <a:p>
+            <a:pPr algn="l">
+              <a:lnSpc>
+                <a:spcPct val="100000"/>
+              </a:lnSpc>
+              <a:spcBef>
+                <a:spcPts val="0"/>
+              </a:spcBef>
+              <a:spcAft>
+                <a:spcPts val="0"/>
+              </a:spcAft>
+            </a:pPr>
+            <a:r>
+              <a:rPr sz="750" b="0">
+                <a:solidFill>
+                  <a:srgbClr val="9AA4B5"/>
+                </a:solidFill>
+                <a:latin typeface="Noto Sans CJK SC"/>
+              </a:rPr>
+              <a:t>MJLAB / PHYSICS BACKEND REVIEW</a:t>
+            </a:r>
+          </a:p>
+        </p:txBody>
+      </p:sp>
+      <p:sp>
+        <p:nvSpPr>
+          <p:cNvPr id="56" name="TextBox 55"/>
+          <p:cNvSpPr txBox="1"/>
+          <p:nvPr/>
+        </p:nvSpPr>
+        <p:spPr>
+          <a:xfrm>
+            <a:off x="10881360" y="6473952"/>
+            <a:ext cx="457200" cy="201168"/>
+          </a:xfrm>
+          <a:prstGeom prst="rect">
+            <a:avLst/>
+          </a:prstGeom>
+          <a:noFill/>
+        </p:spPr>
+        <p:txBody>
+          <a:bodyPr wrap="square" lIns="0" rIns="0" tIns="0" bIns="0" anchor="b">
+            <a:spAutoFit/>
+          </a:bodyPr>
+          <a:lstStyle/>
+          <a:p>
+            <a:pPr algn="r">
+              <a:lnSpc>
+                <a:spcPct val="100000"/>
+              </a:lnSpc>
+              <a:spcBef>
+                <a:spcPts val="0"/>
+              </a:spcBef>
+              <a:spcAft>
+                <a:spcPts val="0"/>
+              </a:spcAft>
+            </a:pPr>
+            <a:r>
+              <a:rPr sz="800" b="0">
+                <a:solidFill>
+                  <a:srgbClr val="9AA4B5"/>
+                </a:solidFill>
+                <a:latin typeface="Noto Sans CJK SC"/>
+              </a:rPr>
+              <a:t>18</a:t>
             </a:r>
           </a:p>
         </p:txBody>

</xml_diff>